<commit_message>
Skalierbarkeitsfolie ergänzen und Abgabe-Branch im README beschreiben
- Neue Hauptfolie 8 «Skalierbarkeit» mit den Messwerten aus scaling_benchmark.csv
  und Sprechernotizen; nachfolgende Folien umnummeriert
- Testzahl auf Folien und in den Notizen von 43 auf 44 korrigiert
- README: Abgabe-Branch abgabe/teil1 verlinkt, Folienverweise und -anzahl angepasst

Co-Authored-By: Claude Opus 5.5 <noreply@anthropic.com>
</commit_message>
<xml_diff>
--- a/presentations/teil1_verkehrsunfaelle_zuerich.pptx
+++ b/presentations/teil1_verkehrsunfaelle_zuerich.pptx
@@ -12,6 +12,7 @@
     <p:sldId id="260" r:id="rId12"/>
     <p:sldId id="261" r:id="rId13"/>
     <p:sldId id="262" r:id="rId14"/>
+    <p:sldId id="274" r:id="rId26"/>
     <p:sldId id="263" r:id="rId15"/>
     <p:sldId id="264" r:id="rId16"/>
     <p:sldId id="265" r:id="rId17"/>
@@ -791,7 +792,7 @@
           <a:p/>
           <a:p>
             <a:r>
-              <a:t>Die technische Prüfung umfasst 43 automatisierte Tests, die Codeprüfung, die Pipeline und beide Notebooks. Ein isolierter Neulauf erzeugt dieselben fachlichen Ergebnisse. Die Datenbank wird vor dem Austausch geprüft. Das zeigt, dass unser Verfahren funktioniert. Es beweist aber nicht, dass die Quelldaten alle tatsächlichen Unfälle enthalten oder dass unsere Zusammenhänge kausal sind. Es fehlen Verkehrsleistung und weitere Einflussgrössen. Daher bleiben die Aussagen auf den registrierten Bestand und das verwendete Modell begrenzt.</a:t>
+              <a:t>Die technische Prüfung umfasst 44 automatisierte Tests, die Codeprüfung, die Pipeline und beide Notebooks. Ein isolierter Neulauf erzeugt dieselben fachlichen Ergebnisse. Die Datenbank wird vor dem Austausch geprüft. Das zeigt, dass unser Verfahren funktioniert. Es beweist aber nicht, dass die Quelldaten alle tatsächlichen Unfälle enthalten oder dass unsere Zusammenhänge kausal sind. Es fehlen Verkehrsleistung und weitere Einflussgrössen. Daher bleiben die Aussagen auf den registrierten Bestand und das verwendete Modell begrenzt.</a:t>
             </a:r>
           </a:p>
           <a:p/>
@@ -1320,6 +1321,99 @@
           <a:p>
             <a:r>
               <a:t>Verstehen: Nur persönlich geprüfte und verstandene Arbeit als eigene Erklärung vertreten.</a:t>
+            </a:r>
+          </a:p>
+        </p:txBody>
+      </p:sp>
+      <p:sp>
+        <p:nvSpPr>
+          <p:cNvPr id="4" name="Slide Number Placeholder 3"/>
+          <p:cNvSpPr>
+            <a:spLocks noGrp="1"/>
+          </p:cNvSpPr>
+          <p:nvPr>
+            <p:ph type="sldNum" idx="5" sz="quarter"/>
+          </p:nvPr>
+        </p:nvSpPr>
+        <p:spPr/>
+      </p:sp>
+    </p:spTree>
+  </p:cSld>
+  <p:clrMapOvr>
+    <a:masterClrMapping/>
+  </p:clrMapOvr>
+</p:notes>
+</file>
+
+<file path=ppt/notesSlides/notesSlide19.xml><?xml version="1.0" encoding="utf-8"?>
+<p:notes xmlns:a="http://schemas.openxmlformats.org/drawingml/2006/main" xmlns:p="http://schemas.openxmlformats.org/presentationml/2006/main" xmlns:r="http://schemas.openxmlformats.org/officeDocument/2006/relationships">
+  <p:cSld>
+    <p:spTree>
+      <p:nvGrpSpPr>
+        <p:cNvPr id="1" name=""/>
+        <p:cNvGrpSpPr/>
+        <p:nvPr/>
+      </p:nvGrpSpPr>
+      <p:grpSpPr>
+        <a:xfrm>
+          <a:off x="0" y="0"/>
+          <a:ext cx="0" cy="0"/>
+          <a:chOff x="0" y="0"/>
+          <a:chExt cx="0" cy="0"/>
+        </a:xfrm>
+      </p:grpSpPr>
+      <p:sp>
+        <p:nvSpPr>
+          <p:cNvPr id="2" name="Slide Image Placeholder 1"/>
+          <p:cNvSpPr>
+            <a:spLocks noGrp="1"/>
+          </p:cNvSpPr>
+          <p:nvPr>
+            <p:ph type="sldImg" idx="2"/>
+          </p:nvPr>
+        </p:nvSpPr>
+        <p:spPr/>
+      </p:sp>
+      <p:sp>
+        <p:nvSpPr>
+          <p:cNvPr id="3" name="Notes Placeholder 2"/>
+          <p:cNvSpPr>
+            <a:spLocks noGrp="1"/>
+          </p:cNvSpPr>
+          <p:nvPr>
+            <p:ph type="body" idx="3" sz="quarter"/>
+          </p:nvPr>
+        </p:nvSpPr>
+        <p:spPr/>
+        <p:txBody>
+          <a:bodyPr/>
+          <a:lstStyle/>
+          <a:p>
+            <a:r>
+              <a:t>Skalierbarkeit gemessen</a:t>
+            </a:r>
+          </a:p>
+          <a:p>
+            <a:r>
+              <a:t>Richtzeit: 45 Sekunden</a:t>
+            </a:r>
+          </a:p>
+          <a:p/>
+          <a:p>
+            <a:r>
+              <a:t>Skalierbarkeit haben wir nicht nur behauptet, sondern gemessen. benchmark.py vervielfacht den echten Snapshot mit neuen, eindeutigen Unfall-IDs und schickt ihn durch die unveränderte Pipeline. Zehnmal mehr Daten brauchen rund zehnmal so lange: Die Laufzeit wächst also etwa linear. Storage braucht rund 70 Prozent der Zeit, weil wir jeden Wert nach dem Speichern kontrollieren. Diese Sicherheit ist uns wichtiger als Tempo.</a:t>
+            </a:r>
+          </a:p>
+          <a:p/>
+          <a:p>
+            <a:r>
+              <a:t>Die eigentliche Grenze ist der Arbeitsspeicher, rund 170 MB je 70’000 Unfälle. Mit 8 GB reicht der Entwurf für das 30- bis 40-Fache des heutigen Bestands. Bei rund 5’000 neuen Unfällen pro Jahr genügt das für Zürich auf Jahrzehnte.</a:t>
+            </a:r>
+          </a:p>
+          <a:p/>
+          <a:p>
+            <a:r>
+              <a:t>Falls mehr nötig wird: Daten blockweise mit Parquet verarbeiten, nur storage.py austauschen (DuckDB oder PostgreSQL) und erst bei mehreren Quellen einen Orchestrator wie Airflow einsetzen.</a:t>
             </a:r>
           </a:p>
         </p:txBody>
@@ -6060,7 +6154,7 @@
               </a:defRPr>
             </a:pPr>
             <a:r>
-              <a:t>09 · ERGEBNIS F2</a:t>
+              <a:t>10 · ERGEBNIS F2</a:t>
             </a:r>
           </a:p>
         </p:txBody>
@@ -6216,7 +6310,7 @@
               </a:defRPr>
             </a:pPr>
             <a:r>
-              <a:t>10</a:t>
+              <a:t>11</a:t>
             </a:r>
           </a:p>
         </p:txBody>
@@ -6762,7 +6856,7 @@
               </a:defRPr>
             </a:pPr>
             <a:r>
-              <a:t>10 · ERGEBNIS F3</a:t>
+              <a:t>11 · ERGEBNIS F3</a:t>
             </a:r>
           </a:p>
         </p:txBody>
@@ -6918,7 +7012,7 @@
               </a:defRPr>
             </a:pPr>
             <a:r>
-              <a:t>11</a:t>
+              <a:t>12</a:t>
             </a:r>
           </a:p>
         </p:txBody>
@@ -7218,7 +7312,7 @@
               </a:defRPr>
             </a:pPr>
             <a:r>
-              <a:t>11 · QUALITÄT UND GRENZEN</a:t>
+              <a:t>12 · QUALITÄT UND GRENZEN</a:t>
             </a:r>
           </a:p>
         </p:txBody>
@@ -7374,7 +7468,7 @@
               </a:defRPr>
             </a:pPr>
             <a:r>
-              <a:t>12</a:t>
+              <a:t>13</a:t>
             </a:r>
           </a:p>
         </p:txBody>
@@ -7540,7 +7634,7 @@
               </a:defRPr>
             </a:pPr>
             <a:r>
-              <a:t>43 Tests und Codeprüfung erfolgreich</a:t>
+              <a:t>44 Tests und Codeprüfung erfolgreich</a:t>
             </a:r>
           </a:p>
           <a:p>
@@ -8026,7 +8120,7 @@
               </a:defRPr>
             </a:pPr>
             <a:r>
-              <a:t>12 · ANTWORTEN AUF DIE FORSCHUNGSFRAGEN</a:t>
+              <a:t>13 · ANTWORTEN AUF DIE FORSCHUNGSFRAGEN</a:t>
             </a:r>
           </a:p>
         </p:txBody>
@@ -8182,7 +8276,7 @@
               </a:defRPr>
             </a:pPr>
             <a:r>
-              <a:t>13</a:t>
+              <a:t>14</a:t>
             </a:r>
           </a:p>
         </p:txBody>
@@ -8860,7 +8954,7 @@
               </a:defRPr>
             </a:pPr>
             <a:r>
-              <a:t>13 · REPRODUZIERBARKEIT UND ABGABE</a:t>
+              <a:t>14 · REPRODUZIERBARKEIT UND ABGABE</a:t>
             </a:r>
           </a:p>
         </p:txBody>
@@ -8977,7 +9071,7 @@
               </a:defRPr>
             </a:pPr>
             <a:r>
-              <a:t>14</a:t>
+              <a:t>15</a:t>
             </a:r>
           </a:p>
         </p:txBody>
@@ -9410,7 +9504,7 @@
               </a:defRPr>
             </a:pPr>
             <a:r>
-              <a:t>43 Tests und Codeprüfung</a:t>
+              <a:t>44 Tests und Codeprüfung</a:t>
             </a:r>
           </a:p>
           <a:p>
@@ -9784,7 +9878,7 @@
               </a:defRPr>
             </a:pPr>
             <a:r>
-              <a:t>15</a:t>
+              <a:t>16</a:t>
             </a:r>
           </a:p>
         </p:txBody>
@@ -10555,7 +10649,7 @@
               </a:defRPr>
             </a:pPr>
             <a:r>
-              <a:t>16</a:t>
+              <a:t>17</a:t>
             </a:r>
           </a:p>
         </p:txBody>
@@ -12284,7 +12378,7 @@
               </a:defRPr>
             </a:pPr>
             <a:r>
-              <a:t>17</a:t>
+              <a:t>18</a:t>
             </a:r>
           </a:p>
         </p:txBody>
@@ -13188,7 +13282,7 @@
               </a:defRPr>
             </a:pPr>
             <a:r>
-              <a:t>18</a:t>
+              <a:t>19</a:t>
             </a:r>
           </a:p>
         </p:txBody>
@@ -13604,6 +13698,1735 @@
             </a:pPr>
             <a:r>
               <a:t>Vollständige Quellen, Methoden und Ausführung: README.md</a:t>
+            </a:r>
+          </a:p>
+        </p:txBody>
+      </p:sp>
+    </p:spTree>
+  </p:cSld>
+  <p:clrMapOvr>
+    <a:masterClrMapping/>
+  </p:clrMapOvr>
+</p:sld>
+</file>
+
+<file path=ppt/slides/slide19.xml><?xml version="1.0" encoding="utf-8"?>
+<p:sld xmlns:a="http://schemas.openxmlformats.org/drawingml/2006/main" xmlns:p="http://schemas.openxmlformats.org/presentationml/2006/main" xmlns:r="http://schemas.openxmlformats.org/officeDocument/2006/relationships">
+  <p:cSld>
+    <p:bg>
+      <p:bgPr>
+        <a:solidFill>
+          <a:srgbClr val="F4F6F5"/>
+        </a:solidFill>
+        <a:effectLst/>
+      </p:bgPr>
+    </p:bg>
+    <p:spTree>
+      <p:nvGrpSpPr>
+        <p:cNvPr id="1" name=""/>
+        <p:cNvGrpSpPr/>
+        <p:nvPr/>
+      </p:nvGrpSpPr>
+      <p:grpSpPr/>
+      <p:sp>
+        <p:nvSpPr>
+          <p:cNvPr id="2" name="Rectangle 1"/>
+          <p:cNvSpPr/>
+          <p:nvPr/>
+        </p:nvSpPr>
+        <p:spPr>
+          <a:xfrm>
+            <a:off x="0" y="0"/>
+            <a:ext cx="12191695" cy="50292"/>
+          </a:xfrm>
+          <a:prstGeom prst="rect">
+            <a:avLst/>
+          </a:prstGeom>
+          <a:solidFill>
+            <a:srgbClr val="087E83"/>
+          </a:solidFill>
+          <a:ln>
+            <a:noFill/>
+          </a:ln>
+        </p:spPr>
+        <p:style>
+          <a:lnRef idx="1">
+            <a:schemeClr val="accent1"/>
+          </a:lnRef>
+          <a:fillRef idx="3">
+            <a:schemeClr val="accent1"/>
+          </a:fillRef>
+          <a:effectRef idx="2">
+            <a:schemeClr val="accent1"/>
+          </a:effectRef>
+          <a:fontRef idx="minor">
+            <a:schemeClr val="lt1"/>
+          </a:fontRef>
+        </p:style>
+        <p:txBody>
+          <a:bodyPr rtlCol="0" anchor="ctr"/>
+          <a:lstStyle/>
+          <a:p>
+            <a:pPr algn="ctr"/>
+          </a:p>
+        </p:txBody>
+      </p:sp>
+      <p:sp>
+        <p:nvSpPr>
+          <p:cNvPr id="3" name="TextBox 2"/>
+          <p:cNvSpPr txBox="1"/>
+          <p:nvPr/>
+        </p:nvSpPr>
+        <p:spPr>
+          <a:xfrm>
+            <a:off x="548640" y="301752"/>
+            <a:ext cx="10789920" cy="292608"/>
+          </a:xfrm>
+          <a:prstGeom prst="rect">
+            <a:avLst/>
+          </a:prstGeom>
+          <a:noFill/>
+        </p:spPr>
+        <p:txBody>
+          <a:bodyPr wrap="square" lIns="13716" rIns="13716" tIns="13716" bIns="13716">
+            <a:spAutoFit/>
+          </a:bodyPr>
+          <a:lstStyle/>
+          <a:p>
+            <a:pPr>
+              <a:spcAft>
+                <a:spcPts val="700"/>
+              </a:spcAft>
+              <a:defRPr sz="1050" b="1">
+                <a:solidFill>
+                  <a:srgbClr val="087E83"/>
+                </a:solidFill>
+                <a:latin typeface="Aptos"/>
+              </a:defRPr>
+            </a:pPr>
+            <a:r>
+              <a:t>07 · SKALIERBARKEIT</a:t>
+            </a:r>
+          </a:p>
+        </p:txBody>
+      </p:sp>
+      <p:sp>
+        <p:nvSpPr>
+          <p:cNvPr id="4" name="TextBox 3"/>
+          <p:cNvSpPr txBox="1"/>
+          <p:nvPr/>
+        </p:nvSpPr>
+        <p:spPr>
+          <a:xfrm>
+            <a:off x="548640" y="795528"/>
+            <a:ext cx="11064240" cy="621792"/>
+          </a:xfrm>
+          <a:prstGeom prst="rect">
+            <a:avLst/>
+          </a:prstGeom>
+          <a:noFill/>
+        </p:spPr>
+        <p:txBody>
+          <a:bodyPr wrap="square" lIns="13716" rIns="13716" tIns="13716" bIns="13716">
+            <a:spAutoFit/>
+          </a:bodyPr>
+          <a:lstStyle/>
+          <a:p>
+            <a:pPr>
+              <a:spcAft>
+                <a:spcPts val="700"/>
+              </a:spcAft>
+              <a:defRPr sz="3100" b="1">
+                <a:solidFill>
+                  <a:srgbClr val="102C3B"/>
+                </a:solidFill>
+                <a:latin typeface="Aptos"/>
+              </a:defRPr>
+            </a:pPr>
+            <a:r>
+              <a:t>Zehnmal mehr Daten brauchen rund zehnmal so lange</a:t>
+            </a:r>
+          </a:p>
+        </p:txBody>
+      </p:sp>
+      <p:sp>
+        <p:nvSpPr>
+          <p:cNvPr id="5" name="TextBox 4"/>
+          <p:cNvSpPr txBox="1"/>
+          <p:nvPr/>
+        </p:nvSpPr>
+        <p:spPr>
+          <a:xfrm>
+            <a:off x="548640" y="1490472"/>
+            <a:ext cx="11064240" cy="548640"/>
+          </a:xfrm>
+          <a:prstGeom prst="rect">
+            <a:avLst/>
+          </a:prstGeom>
+          <a:noFill/>
+        </p:spPr>
+        <p:txBody>
+          <a:bodyPr wrap="square" lIns="13716" rIns="13716" tIns="13716" bIns="13716">
+            <a:spAutoFit/>
+          </a:bodyPr>
+          <a:lstStyle/>
+          <a:p>
+            <a:pPr>
+              <a:spcAft>
+                <a:spcPts val="700"/>
+              </a:spcAft>
+              <a:defRPr sz="1700" b="0">
+                <a:solidFill>
+                  <a:srgbClr val="536773"/>
+                </a:solidFill>
+                <a:latin typeface="Aptos"/>
+              </a:defRPr>
+            </a:pPr>
+            <a:r>
+              <a:t>Gemessen: echter Snapshot vervielfacht, unveränderte Pipeline · Storage ≈ 70 % der Zeit</a:t>
+            </a:r>
+          </a:p>
+        </p:txBody>
+      </p:sp>
+      <p:sp>
+        <p:nvSpPr>
+          <p:cNvPr id="6" name="TextBox 5"/>
+          <p:cNvSpPr txBox="1"/>
+          <p:nvPr/>
+        </p:nvSpPr>
+        <p:spPr>
+          <a:xfrm>
+            <a:off x="548640" y="6519672"/>
+            <a:ext cx="9966960" cy="182880"/>
+          </a:xfrm>
+          <a:prstGeom prst="rect">
+            <a:avLst/>
+          </a:prstGeom>
+          <a:noFill/>
+        </p:spPr>
+        <p:txBody>
+          <a:bodyPr wrap="square" lIns="13716" rIns="13716" tIns="13716" bIns="13716">
+            <a:spAutoFit/>
+          </a:bodyPr>
+          <a:lstStyle/>
+          <a:p>
+            <a:pPr>
+              <a:spcAft>
+                <a:spcPts val="700"/>
+              </a:spcAft>
+              <a:defRPr sz="900" b="0">
+                <a:solidFill>
+                  <a:srgbClr val="536773"/>
+                </a:solidFill>
+                <a:latin typeface="Aptos"/>
+              </a:defRPr>
+            </a:pPr>
+            <a:r>
+              <a:t>ZHAW · Data Engineering HS26 · Souto / Fawaz / Muslija</a:t>
+            </a:r>
+          </a:p>
+        </p:txBody>
+      </p:sp>
+      <p:sp>
+        <p:nvSpPr>
+          <p:cNvPr id="7" name="TextBox 6"/>
+          <p:cNvSpPr txBox="1"/>
+          <p:nvPr/>
+        </p:nvSpPr>
+        <p:spPr>
+          <a:xfrm>
+            <a:off x="10991088" y="6473952"/>
+            <a:ext cx="640080" cy="274320"/>
+          </a:xfrm>
+          <a:prstGeom prst="rect">
+            <a:avLst/>
+          </a:prstGeom>
+          <a:noFill/>
+        </p:spPr>
+        <p:txBody>
+          <a:bodyPr wrap="square" lIns="13716" rIns="13716" tIns="13716" bIns="13716">
+            <a:spAutoFit/>
+          </a:bodyPr>
+          <a:lstStyle/>
+          <a:p>
+            <a:pPr>
+              <a:spcAft>
+                <a:spcPts val="700"/>
+              </a:spcAft>
+              <a:defRPr sz="1100" b="1">
+                <a:solidFill>
+                  <a:srgbClr val="087E83"/>
+                </a:solidFill>
+                <a:latin typeface="Aptos"/>
+              </a:defRPr>
+            </a:pPr>
+            <a:r>
+              <a:t>08</a:t>
+            </a:r>
+          </a:p>
+        </p:txBody>
+      </p:sp>
+      <p:sp>
+        <p:nvSpPr>
+          <p:cNvPr id="8" name="TextBox 7"/>
+          <p:cNvSpPr txBox="1"/>
+          <p:nvPr/>
+        </p:nvSpPr>
+        <p:spPr>
+          <a:xfrm>
+            <a:off x="731520" y="2258568"/>
+            <a:ext cx="1463040" cy="457200"/>
+          </a:xfrm>
+          <a:prstGeom prst="rect">
+            <a:avLst/>
+          </a:prstGeom>
+          <a:noFill/>
+        </p:spPr>
+        <p:txBody>
+          <a:bodyPr wrap="square" lIns="13716" rIns="13716" tIns="13716" bIns="13716">
+            <a:spAutoFit/>
+          </a:bodyPr>
+          <a:lstStyle/>
+          <a:p>
+            <a:pPr>
+              <a:spcAft>
+                <a:spcPts val="700"/>
+              </a:spcAft>
+              <a:defRPr sz="1700" b="1">
+                <a:solidFill>
+                  <a:srgbClr val="087E83"/>
+                </a:solidFill>
+                <a:latin typeface="Aptos"/>
+              </a:defRPr>
+            </a:pPr>
+            <a:r>
+              <a:t>Faktor</a:t>
+            </a:r>
+          </a:p>
+        </p:txBody>
+      </p:sp>
+      <p:sp>
+        <p:nvSpPr>
+          <p:cNvPr id="9" name="TextBox 8"/>
+          <p:cNvSpPr txBox="1"/>
+          <p:nvPr/>
+        </p:nvSpPr>
+        <p:spPr>
+          <a:xfrm>
+            <a:off x="2286000" y="2258568"/>
+            <a:ext cx="1691640" cy="457200"/>
+          </a:xfrm>
+          <a:prstGeom prst="rect">
+            <a:avLst/>
+          </a:prstGeom>
+          <a:noFill/>
+        </p:spPr>
+        <p:txBody>
+          <a:bodyPr wrap="square" lIns="13716" rIns="13716" tIns="13716" bIns="13716">
+            <a:spAutoFit/>
+          </a:bodyPr>
+          <a:lstStyle/>
+          <a:p>
+            <a:pPr>
+              <a:spcAft>
+                <a:spcPts val="700"/>
+              </a:spcAft>
+              <a:defRPr sz="1700" b="1">
+                <a:solidFill>
+                  <a:srgbClr val="087E83"/>
+                </a:solidFill>
+                <a:latin typeface="Aptos"/>
+              </a:defRPr>
+            </a:pPr>
+            <a:r>
+              <a:t>Unfälle</a:t>
+            </a:r>
+          </a:p>
+        </p:txBody>
+      </p:sp>
+      <p:sp>
+        <p:nvSpPr>
+          <p:cNvPr id="10" name="TextBox 9"/>
+          <p:cNvSpPr txBox="1"/>
+          <p:nvPr/>
+        </p:nvSpPr>
+        <p:spPr>
+          <a:xfrm>
+            <a:off x="4069080" y="2258568"/>
+            <a:ext cx="1965960" cy="457200"/>
+          </a:xfrm>
+          <a:prstGeom prst="rect">
+            <a:avLst/>
+          </a:prstGeom>
+          <a:noFill/>
+        </p:spPr>
+        <p:txBody>
+          <a:bodyPr wrap="square" lIns="13716" rIns="13716" tIns="13716" bIns="13716">
+            <a:spAutoFit/>
+          </a:bodyPr>
+          <a:lstStyle/>
+          <a:p>
+            <a:pPr>
+              <a:spcAft>
+                <a:spcPts val="700"/>
+              </a:spcAft>
+              <a:defRPr sz="1700" b="1">
+                <a:solidFill>
+                  <a:srgbClr val="087E83"/>
+                </a:solidFill>
+                <a:latin typeface="Aptos"/>
+              </a:defRPr>
+            </a:pPr>
+            <a:r>
+              <a:t>Transformation</a:t>
+            </a:r>
+          </a:p>
+        </p:txBody>
+      </p:sp>
+      <p:sp>
+        <p:nvSpPr>
+          <p:cNvPr id="11" name="TextBox 10"/>
+          <p:cNvSpPr txBox="1"/>
+          <p:nvPr/>
+        </p:nvSpPr>
+        <p:spPr>
+          <a:xfrm>
+            <a:off x="6172200" y="2258568"/>
+            <a:ext cx="1600200" cy="457200"/>
+          </a:xfrm>
+          <a:prstGeom prst="rect">
+            <a:avLst/>
+          </a:prstGeom>
+          <a:noFill/>
+        </p:spPr>
+        <p:txBody>
+          <a:bodyPr wrap="square" lIns="13716" rIns="13716" tIns="13716" bIns="13716">
+            <a:spAutoFit/>
+          </a:bodyPr>
+          <a:lstStyle/>
+          <a:p>
+            <a:pPr>
+              <a:spcAft>
+                <a:spcPts val="700"/>
+              </a:spcAft>
+              <a:defRPr sz="1700" b="1">
+                <a:solidFill>
+                  <a:srgbClr val="087E83"/>
+                </a:solidFill>
+                <a:latin typeface="Aptos"/>
+              </a:defRPr>
+            </a:pPr>
+            <a:r>
+              <a:t>Storage</a:t>
+            </a:r>
+          </a:p>
+        </p:txBody>
+      </p:sp>
+      <p:sp>
+        <p:nvSpPr>
+          <p:cNvPr id="12" name="TextBox 11"/>
+          <p:cNvSpPr txBox="1"/>
+          <p:nvPr/>
+        </p:nvSpPr>
+        <p:spPr>
+          <a:xfrm>
+            <a:off x="7863840" y="2258568"/>
+            <a:ext cx="1463040" cy="457200"/>
+          </a:xfrm>
+          <a:prstGeom prst="rect">
+            <a:avLst/>
+          </a:prstGeom>
+          <a:noFill/>
+        </p:spPr>
+        <p:txBody>
+          <a:bodyPr wrap="square" lIns="13716" rIns="13716" tIns="13716" bIns="13716">
+            <a:spAutoFit/>
+          </a:bodyPr>
+          <a:lstStyle/>
+          <a:p>
+            <a:pPr>
+              <a:spcAft>
+                <a:spcPts val="700"/>
+              </a:spcAft>
+              <a:defRPr sz="1700" b="1">
+                <a:solidFill>
+                  <a:srgbClr val="087E83"/>
+                </a:solidFill>
+                <a:latin typeface="Aptos"/>
+              </a:defRPr>
+            </a:pPr>
+            <a:r>
+              <a:t>Total</a:t>
+            </a:r>
+          </a:p>
+        </p:txBody>
+      </p:sp>
+      <p:sp>
+        <p:nvSpPr>
+          <p:cNvPr id="13" name="TextBox 12"/>
+          <p:cNvSpPr txBox="1"/>
+          <p:nvPr/>
+        </p:nvSpPr>
+        <p:spPr>
+          <a:xfrm>
+            <a:off x="9418320" y="2258568"/>
+            <a:ext cx="2011680" cy="457200"/>
+          </a:xfrm>
+          <a:prstGeom prst="rect">
+            <a:avLst/>
+          </a:prstGeom>
+          <a:noFill/>
+        </p:spPr>
+        <p:txBody>
+          <a:bodyPr wrap="square" lIns="13716" rIns="13716" tIns="13716" bIns="13716">
+            <a:spAutoFit/>
+          </a:bodyPr>
+          <a:lstStyle/>
+          <a:p>
+            <a:pPr>
+              <a:spcAft>
+                <a:spcPts val="700"/>
+              </a:spcAft>
+              <a:defRPr sz="1700" b="1">
+                <a:solidFill>
+                  <a:srgbClr val="087E83"/>
+                </a:solidFill>
+                <a:latin typeface="Aptos"/>
+              </a:defRPr>
+            </a:pPr>
+            <a:r>
+              <a:t>Arbeitsspeicher</a:t>
+            </a:r>
+          </a:p>
+        </p:txBody>
+      </p:sp>
+      <p:sp>
+        <p:nvSpPr>
+          <p:cNvPr id="14" name="Rectangle 13"/>
+          <p:cNvSpPr/>
+          <p:nvPr/>
+        </p:nvSpPr>
+        <p:spPr>
+          <a:xfrm>
+            <a:off x="548640" y="2807208"/>
+            <a:ext cx="11064240" cy="539496"/>
+          </a:xfrm>
+          <a:prstGeom prst="rect">
+            <a:avLst/>
+          </a:prstGeom>
+          <a:solidFill>
+            <a:srgbClr val="FFFFFF"/>
+          </a:solidFill>
+          <a:ln>
+            <a:noFill/>
+          </a:ln>
+        </p:spPr>
+        <p:style>
+          <a:lnRef idx="1">
+            <a:schemeClr val="accent1"/>
+          </a:lnRef>
+          <a:fillRef idx="3">
+            <a:schemeClr val="accent1"/>
+          </a:fillRef>
+          <a:effectRef idx="2">
+            <a:schemeClr val="accent1"/>
+          </a:effectRef>
+          <a:fontRef idx="minor">
+            <a:schemeClr val="lt1"/>
+          </a:fontRef>
+        </p:style>
+        <p:txBody>
+          <a:bodyPr rtlCol="0" anchor="ctr"/>
+          <a:lstStyle/>
+          <a:p>
+            <a:pPr algn="ctr"/>
+          </a:p>
+        </p:txBody>
+      </p:sp>
+      <p:sp>
+        <p:nvSpPr>
+          <p:cNvPr id="15" name="TextBox 14"/>
+          <p:cNvSpPr txBox="1"/>
+          <p:nvPr/>
+        </p:nvSpPr>
+        <p:spPr>
+          <a:xfrm>
+            <a:off x="731520" y="2880360"/>
+            <a:ext cx="1463040" cy="393192"/>
+          </a:xfrm>
+          <a:prstGeom prst="rect">
+            <a:avLst/>
+          </a:prstGeom>
+          <a:noFill/>
+        </p:spPr>
+        <p:txBody>
+          <a:bodyPr wrap="square" lIns="13716" rIns="13716" tIns="13716" bIns="13716">
+            <a:spAutoFit/>
+          </a:bodyPr>
+          <a:lstStyle/>
+          <a:p>
+            <a:pPr>
+              <a:spcAft>
+                <a:spcPts val="700"/>
+              </a:spcAft>
+              <a:defRPr sz="1700" b="0">
+                <a:solidFill>
+                  <a:srgbClr val="102C3B"/>
+                </a:solidFill>
+                <a:latin typeface="Aptos"/>
+              </a:defRPr>
+            </a:pPr>
+            <a:r>
+              <a:t>1×</a:t>
+            </a:r>
+          </a:p>
+        </p:txBody>
+      </p:sp>
+      <p:sp>
+        <p:nvSpPr>
+          <p:cNvPr id="16" name="TextBox 15"/>
+          <p:cNvSpPr txBox="1"/>
+          <p:nvPr/>
+        </p:nvSpPr>
+        <p:spPr>
+          <a:xfrm>
+            <a:off x="2286000" y="2880360"/>
+            <a:ext cx="1691640" cy="393192"/>
+          </a:xfrm>
+          <a:prstGeom prst="rect">
+            <a:avLst/>
+          </a:prstGeom>
+          <a:noFill/>
+        </p:spPr>
+        <p:txBody>
+          <a:bodyPr wrap="square" lIns="13716" rIns="13716" tIns="13716" bIns="13716">
+            <a:spAutoFit/>
+          </a:bodyPr>
+          <a:lstStyle/>
+          <a:p>
+            <a:pPr>
+              <a:spcAft>
+                <a:spcPts val="700"/>
+              </a:spcAft>
+              <a:defRPr sz="1700" b="0">
+                <a:solidFill>
+                  <a:srgbClr val="102C3B"/>
+                </a:solidFill>
+                <a:latin typeface="Aptos"/>
+              </a:defRPr>
+            </a:pPr>
+            <a:r>
+              <a:t>70’767</a:t>
+            </a:r>
+          </a:p>
+        </p:txBody>
+      </p:sp>
+      <p:sp>
+        <p:nvSpPr>
+          <p:cNvPr id="17" name="TextBox 16"/>
+          <p:cNvSpPr txBox="1"/>
+          <p:nvPr/>
+        </p:nvSpPr>
+        <p:spPr>
+          <a:xfrm>
+            <a:off x="4069080" y="2880360"/>
+            <a:ext cx="1965960" cy="393192"/>
+          </a:xfrm>
+          <a:prstGeom prst="rect">
+            <a:avLst/>
+          </a:prstGeom>
+          <a:noFill/>
+        </p:spPr>
+        <p:txBody>
+          <a:bodyPr wrap="square" lIns="13716" rIns="13716" tIns="13716" bIns="13716">
+            <a:spAutoFit/>
+          </a:bodyPr>
+          <a:lstStyle/>
+          <a:p>
+            <a:pPr>
+              <a:spcAft>
+                <a:spcPts val="700"/>
+              </a:spcAft>
+              <a:defRPr sz="1700" b="0">
+                <a:solidFill>
+                  <a:srgbClr val="102C3B"/>
+                </a:solidFill>
+                <a:latin typeface="Aptos"/>
+              </a:defRPr>
+            </a:pPr>
+            <a:r>
+              <a:t>1,4 s</a:t>
+            </a:r>
+          </a:p>
+        </p:txBody>
+      </p:sp>
+      <p:sp>
+        <p:nvSpPr>
+          <p:cNvPr id="18" name="TextBox 17"/>
+          <p:cNvSpPr txBox="1"/>
+          <p:nvPr/>
+        </p:nvSpPr>
+        <p:spPr>
+          <a:xfrm>
+            <a:off x="6172200" y="2880360"/>
+            <a:ext cx="1600200" cy="393192"/>
+          </a:xfrm>
+          <a:prstGeom prst="rect">
+            <a:avLst/>
+          </a:prstGeom>
+          <a:noFill/>
+        </p:spPr>
+        <p:txBody>
+          <a:bodyPr wrap="square" lIns="13716" rIns="13716" tIns="13716" bIns="13716">
+            <a:spAutoFit/>
+          </a:bodyPr>
+          <a:lstStyle/>
+          <a:p>
+            <a:pPr>
+              <a:spcAft>
+                <a:spcPts val="700"/>
+              </a:spcAft>
+              <a:defRPr sz="1700" b="0">
+                <a:solidFill>
+                  <a:srgbClr val="102C3B"/>
+                </a:solidFill>
+                <a:latin typeface="Aptos"/>
+              </a:defRPr>
+            </a:pPr>
+            <a:r>
+              <a:t>3,5 s</a:t>
+            </a:r>
+          </a:p>
+        </p:txBody>
+      </p:sp>
+      <p:sp>
+        <p:nvSpPr>
+          <p:cNvPr id="19" name="TextBox 18"/>
+          <p:cNvSpPr txBox="1"/>
+          <p:nvPr/>
+        </p:nvSpPr>
+        <p:spPr>
+          <a:xfrm>
+            <a:off x="7863840" y="2880360"/>
+            <a:ext cx="1463040" cy="393192"/>
+          </a:xfrm>
+          <a:prstGeom prst="rect">
+            <a:avLst/>
+          </a:prstGeom>
+          <a:noFill/>
+        </p:spPr>
+        <p:txBody>
+          <a:bodyPr wrap="square" lIns="13716" rIns="13716" tIns="13716" bIns="13716">
+            <a:spAutoFit/>
+          </a:bodyPr>
+          <a:lstStyle/>
+          <a:p>
+            <a:pPr>
+              <a:spcAft>
+                <a:spcPts val="700"/>
+              </a:spcAft>
+              <a:defRPr sz="1700" b="0">
+                <a:solidFill>
+                  <a:srgbClr val="102C3B"/>
+                </a:solidFill>
+                <a:latin typeface="Aptos"/>
+              </a:defRPr>
+            </a:pPr>
+            <a:r>
+              <a:t>5,2 s</a:t>
+            </a:r>
+          </a:p>
+        </p:txBody>
+      </p:sp>
+      <p:sp>
+        <p:nvSpPr>
+          <p:cNvPr id="20" name="TextBox 19"/>
+          <p:cNvSpPr txBox="1"/>
+          <p:nvPr/>
+        </p:nvSpPr>
+        <p:spPr>
+          <a:xfrm>
+            <a:off x="9418320" y="2880360"/>
+            <a:ext cx="2011680" cy="393192"/>
+          </a:xfrm>
+          <a:prstGeom prst="rect">
+            <a:avLst/>
+          </a:prstGeom>
+          <a:noFill/>
+        </p:spPr>
+        <p:txBody>
+          <a:bodyPr wrap="square" lIns="13716" rIns="13716" tIns="13716" bIns="13716">
+            <a:spAutoFit/>
+          </a:bodyPr>
+          <a:lstStyle/>
+          <a:p>
+            <a:pPr>
+              <a:spcAft>
+                <a:spcPts val="700"/>
+              </a:spcAft>
+              <a:defRPr sz="1700" b="0">
+                <a:solidFill>
+                  <a:srgbClr val="102C3B"/>
+                </a:solidFill>
+                <a:latin typeface="Aptos"/>
+              </a:defRPr>
+            </a:pPr>
+            <a:r>
+              <a:t>304 MB</a:t>
+            </a:r>
+          </a:p>
+        </p:txBody>
+      </p:sp>
+      <p:sp>
+        <p:nvSpPr>
+          <p:cNvPr id="21" name="Rectangle 20"/>
+          <p:cNvSpPr/>
+          <p:nvPr/>
+        </p:nvSpPr>
+        <p:spPr>
+          <a:xfrm>
+            <a:off x="548640" y="3392424"/>
+            <a:ext cx="11064240" cy="539496"/>
+          </a:xfrm>
+          <a:prstGeom prst="rect">
+            <a:avLst/>
+          </a:prstGeom>
+          <a:solidFill>
+            <a:srgbClr val="E3EFED"/>
+          </a:solidFill>
+          <a:ln>
+            <a:noFill/>
+          </a:ln>
+        </p:spPr>
+        <p:style>
+          <a:lnRef idx="1">
+            <a:schemeClr val="accent1"/>
+          </a:lnRef>
+          <a:fillRef idx="3">
+            <a:schemeClr val="accent1"/>
+          </a:fillRef>
+          <a:effectRef idx="2">
+            <a:schemeClr val="accent1"/>
+          </a:effectRef>
+          <a:fontRef idx="minor">
+            <a:schemeClr val="lt1"/>
+          </a:fontRef>
+        </p:style>
+        <p:txBody>
+          <a:bodyPr rtlCol="0" anchor="ctr"/>
+          <a:lstStyle/>
+          <a:p>
+            <a:pPr algn="ctr"/>
+          </a:p>
+        </p:txBody>
+      </p:sp>
+      <p:sp>
+        <p:nvSpPr>
+          <p:cNvPr id="22" name="TextBox 21"/>
+          <p:cNvSpPr txBox="1"/>
+          <p:nvPr/>
+        </p:nvSpPr>
+        <p:spPr>
+          <a:xfrm>
+            <a:off x="731520" y="3465576"/>
+            <a:ext cx="1463040" cy="393192"/>
+          </a:xfrm>
+          <a:prstGeom prst="rect">
+            <a:avLst/>
+          </a:prstGeom>
+          <a:noFill/>
+        </p:spPr>
+        <p:txBody>
+          <a:bodyPr wrap="square" lIns="13716" rIns="13716" tIns="13716" bIns="13716">
+            <a:spAutoFit/>
+          </a:bodyPr>
+          <a:lstStyle/>
+          <a:p>
+            <a:pPr>
+              <a:spcAft>
+                <a:spcPts val="700"/>
+              </a:spcAft>
+              <a:defRPr sz="1700" b="0">
+                <a:solidFill>
+                  <a:srgbClr val="102C3B"/>
+                </a:solidFill>
+                <a:latin typeface="Aptos"/>
+              </a:defRPr>
+            </a:pPr>
+            <a:r>
+              <a:t>2×</a:t>
+            </a:r>
+          </a:p>
+        </p:txBody>
+      </p:sp>
+      <p:sp>
+        <p:nvSpPr>
+          <p:cNvPr id="23" name="TextBox 22"/>
+          <p:cNvSpPr txBox="1"/>
+          <p:nvPr/>
+        </p:nvSpPr>
+        <p:spPr>
+          <a:xfrm>
+            <a:off x="2286000" y="3465576"/>
+            <a:ext cx="1691640" cy="393192"/>
+          </a:xfrm>
+          <a:prstGeom prst="rect">
+            <a:avLst/>
+          </a:prstGeom>
+          <a:noFill/>
+        </p:spPr>
+        <p:txBody>
+          <a:bodyPr wrap="square" lIns="13716" rIns="13716" tIns="13716" bIns="13716">
+            <a:spAutoFit/>
+          </a:bodyPr>
+          <a:lstStyle/>
+          <a:p>
+            <a:pPr>
+              <a:spcAft>
+                <a:spcPts val="700"/>
+              </a:spcAft>
+              <a:defRPr sz="1700" b="0">
+                <a:solidFill>
+                  <a:srgbClr val="102C3B"/>
+                </a:solidFill>
+                <a:latin typeface="Aptos"/>
+              </a:defRPr>
+            </a:pPr>
+            <a:r>
+              <a:t>141’534</a:t>
+            </a:r>
+          </a:p>
+        </p:txBody>
+      </p:sp>
+      <p:sp>
+        <p:nvSpPr>
+          <p:cNvPr id="24" name="TextBox 23"/>
+          <p:cNvSpPr txBox="1"/>
+          <p:nvPr/>
+        </p:nvSpPr>
+        <p:spPr>
+          <a:xfrm>
+            <a:off x="4069080" y="3465576"/>
+            <a:ext cx="1965960" cy="393192"/>
+          </a:xfrm>
+          <a:prstGeom prst="rect">
+            <a:avLst/>
+          </a:prstGeom>
+          <a:noFill/>
+        </p:spPr>
+        <p:txBody>
+          <a:bodyPr wrap="square" lIns="13716" rIns="13716" tIns="13716" bIns="13716">
+            <a:spAutoFit/>
+          </a:bodyPr>
+          <a:lstStyle/>
+          <a:p>
+            <a:pPr>
+              <a:spcAft>
+                <a:spcPts val="700"/>
+              </a:spcAft>
+              <a:defRPr sz="1700" b="0">
+                <a:solidFill>
+                  <a:srgbClr val="102C3B"/>
+                </a:solidFill>
+                <a:latin typeface="Aptos"/>
+              </a:defRPr>
+            </a:pPr>
+            <a:r>
+              <a:t>2,9 s</a:t>
+            </a:r>
+          </a:p>
+        </p:txBody>
+      </p:sp>
+      <p:sp>
+        <p:nvSpPr>
+          <p:cNvPr id="25" name="TextBox 24"/>
+          <p:cNvSpPr txBox="1"/>
+          <p:nvPr/>
+        </p:nvSpPr>
+        <p:spPr>
+          <a:xfrm>
+            <a:off x="6172200" y="3465576"/>
+            <a:ext cx="1600200" cy="393192"/>
+          </a:xfrm>
+          <a:prstGeom prst="rect">
+            <a:avLst/>
+          </a:prstGeom>
+          <a:noFill/>
+        </p:spPr>
+        <p:txBody>
+          <a:bodyPr wrap="square" lIns="13716" rIns="13716" tIns="13716" bIns="13716">
+            <a:spAutoFit/>
+          </a:bodyPr>
+          <a:lstStyle/>
+          <a:p>
+            <a:pPr>
+              <a:spcAft>
+                <a:spcPts val="700"/>
+              </a:spcAft>
+              <a:defRPr sz="1700" b="0">
+                <a:solidFill>
+                  <a:srgbClr val="102C3B"/>
+                </a:solidFill>
+                <a:latin typeface="Aptos"/>
+              </a:defRPr>
+            </a:pPr>
+            <a:r>
+              <a:t>6,2 s</a:t>
+            </a:r>
+          </a:p>
+        </p:txBody>
+      </p:sp>
+      <p:sp>
+        <p:nvSpPr>
+          <p:cNvPr id="26" name="TextBox 25"/>
+          <p:cNvSpPr txBox="1"/>
+          <p:nvPr/>
+        </p:nvSpPr>
+        <p:spPr>
+          <a:xfrm>
+            <a:off x="7863840" y="3465576"/>
+            <a:ext cx="1463040" cy="393192"/>
+          </a:xfrm>
+          <a:prstGeom prst="rect">
+            <a:avLst/>
+          </a:prstGeom>
+          <a:noFill/>
+        </p:spPr>
+        <p:txBody>
+          <a:bodyPr wrap="square" lIns="13716" rIns="13716" tIns="13716" bIns="13716">
+            <a:spAutoFit/>
+          </a:bodyPr>
+          <a:lstStyle/>
+          <a:p>
+            <a:pPr>
+              <a:spcAft>
+                <a:spcPts val="700"/>
+              </a:spcAft>
+              <a:defRPr sz="1700" b="0">
+                <a:solidFill>
+                  <a:srgbClr val="102C3B"/>
+                </a:solidFill>
+                <a:latin typeface="Aptos"/>
+              </a:defRPr>
+            </a:pPr>
+            <a:r>
+              <a:t>9,6 s</a:t>
+            </a:r>
+          </a:p>
+        </p:txBody>
+      </p:sp>
+      <p:sp>
+        <p:nvSpPr>
+          <p:cNvPr id="27" name="TextBox 26"/>
+          <p:cNvSpPr txBox="1"/>
+          <p:nvPr/>
+        </p:nvSpPr>
+        <p:spPr>
+          <a:xfrm>
+            <a:off x="9418320" y="3465576"/>
+            <a:ext cx="2011680" cy="393192"/>
+          </a:xfrm>
+          <a:prstGeom prst="rect">
+            <a:avLst/>
+          </a:prstGeom>
+          <a:noFill/>
+        </p:spPr>
+        <p:txBody>
+          <a:bodyPr wrap="square" lIns="13716" rIns="13716" tIns="13716" bIns="13716">
+            <a:spAutoFit/>
+          </a:bodyPr>
+          <a:lstStyle/>
+          <a:p>
+            <a:pPr>
+              <a:spcAft>
+                <a:spcPts val="700"/>
+              </a:spcAft>
+              <a:defRPr sz="1700" b="0">
+                <a:solidFill>
+                  <a:srgbClr val="102C3B"/>
+                </a:solidFill>
+                <a:latin typeface="Aptos"/>
+              </a:defRPr>
+            </a:pPr>
+            <a:r>
+              <a:t>440 MB</a:t>
+            </a:r>
+          </a:p>
+        </p:txBody>
+      </p:sp>
+      <p:sp>
+        <p:nvSpPr>
+          <p:cNvPr id="28" name="Rectangle 27"/>
+          <p:cNvSpPr/>
+          <p:nvPr/>
+        </p:nvSpPr>
+        <p:spPr>
+          <a:xfrm>
+            <a:off x="548640" y="3977639"/>
+            <a:ext cx="11064240" cy="539496"/>
+          </a:xfrm>
+          <a:prstGeom prst="rect">
+            <a:avLst/>
+          </a:prstGeom>
+          <a:solidFill>
+            <a:srgbClr val="FFFFFF"/>
+          </a:solidFill>
+          <a:ln>
+            <a:noFill/>
+          </a:ln>
+        </p:spPr>
+        <p:style>
+          <a:lnRef idx="1">
+            <a:schemeClr val="accent1"/>
+          </a:lnRef>
+          <a:fillRef idx="3">
+            <a:schemeClr val="accent1"/>
+          </a:fillRef>
+          <a:effectRef idx="2">
+            <a:schemeClr val="accent1"/>
+          </a:effectRef>
+          <a:fontRef idx="minor">
+            <a:schemeClr val="lt1"/>
+          </a:fontRef>
+        </p:style>
+        <p:txBody>
+          <a:bodyPr rtlCol="0" anchor="ctr"/>
+          <a:lstStyle/>
+          <a:p>
+            <a:pPr algn="ctr"/>
+          </a:p>
+        </p:txBody>
+      </p:sp>
+      <p:sp>
+        <p:nvSpPr>
+          <p:cNvPr id="29" name="TextBox 28"/>
+          <p:cNvSpPr txBox="1"/>
+          <p:nvPr/>
+        </p:nvSpPr>
+        <p:spPr>
+          <a:xfrm>
+            <a:off x="731520" y="4050791"/>
+            <a:ext cx="1463040" cy="393192"/>
+          </a:xfrm>
+          <a:prstGeom prst="rect">
+            <a:avLst/>
+          </a:prstGeom>
+          <a:noFill/>
+        </p:spPr>
+        <p:txBody>
+          <a:bodyPr wrap="square" lIns="13716" rIns="13716" tIns="13716" bIns="13716">
+            <a:spAutoFit/>
+          </a:bodyPr>
+          <a:lstStyle/>
+          <a:p>
+            <a:pPr>
+              <a:spcAft>
+                <a:spcPts val="700"/>
+              </a:spcAft>
+              <a:defRPr sz="1700" b="0">
+                <a:solidFill>
+                  <a:srgbClr val="102C3B"/>
+                </a:solidFill>
+                <a:latin typeface="Aptos"/>
+              </a:defRPr>
+            </a:pPr>
+            <a:r>
+              <a:t>5×</a:t>
+            </a:r>
+          </a:p>
+        </p:txBody>
+      </p:sp>
+      <p:sp>
+        <p:nvSpPr>
+          <p:cNvPr id="30" name="TextBox 29"/>
+          <p:cNvSpPr txBox="1"/>
+          <p:nvPr/>
+        </p:nvSpPr>
+        <p:spPr>
+          <a:xfrm>
+            <a:off x="2286000" y="4050791"/>
+            <a:ext cx="1691640" cy="393192"/>
+          </a:xfrm>
+          <a:prstGeom prst="rect">
+            <a:avLst/>
+          </a:prstGeom>
+          <a:noFill/>
+        </p:spPr>
+        <p:txBody>
+          <a:bodyPr wrap="square" lIns="13716" rIns="13716" tIns="13716" bIns="13716">
+            <a:spAutoFit/>
+          </a:bodyPr>
+          <a:lstStyle/>
+          <a:p>
+            <a:pPr>
+              <a:spcAft>
+                <a:spcPts val="700"/>
+              </a:spcAft>
+              <a:defRPr sz="1700" b="0">
+                <a:solidFill>
+                  <a:srgbClr val="102C3B"/>
+                </a:solidFill>
+                <a:latin typeface="Aptos"/>
+              </a:defRPr>
+            </a:pPr>
+            <a:r>
+              <a:t>353’835</a:t>
+            </a:r>
+          </a:p>
+        </p:txBody>
+      </p:sp>
+      <p:sp>
+        <p:nvSpPr>
+          <p:cNvPr id="31" name="TextBox 30"/>
+          <p:cNvSpPr txBox="1"/>
+          <p:nvPr/>
+        </p:nvSpPr>
+        <p:spPr>
+          <a:xfrm>
+            <a:off x="4069080" y="4050791"/>
+            <a:ext cx="1965960" cy="393192"/>
+          </a:xfrm>
+          <a:prstGeom prst="rect">
+            <a:avLst/>
+          </a:prstGeom>
+          <a:noFill/>
+        </p:spPr>
+        <p:txBody>
+          <a:bodyPr wrap="square" lIns="13716" rIns="13716" tIns="13716" bIns="13716">
+            <a:spAutoFit/>
+          </a:bodyPr>
+          <a:lstStyle/>
+          <a:p>
+            <a:pPr>
+              <a:spcAft>
+                <a:spcPts val="700"/>
+              </a:spcAft>
+              <a:defRPr sz="1700" b="0">
+                <a:solidFill>
+                  <a:srgbClr val="102C3B"/>
+                </a:solidFill>
+                <a:latin typeface="Aptos"/>
+              </a:defRPr>
+            </a:pPr>
+            <a:r>
+              <a:t>7,1 s</a:t>
+            </a:r>
+          </a:p>
+        </p:txBody>
+      </p:sp>
+      <p:sp>
+        <p:nvSpPr>
+          <p:cNvPr id="32" name="TextBox 31"/>
+          <p:cNvSpPr txBox="1"/>
+          <p:nvPr/>
+        </p:nvSpPr>
+        <p:spPr>
+          <a:xfrm>
+            <a:off x="6172200" y="4050791"/>
+            <a:ext cx="1600200" cy="393192"/>
+          </a:xfrm>
+          <a:prstGeom prst="rect">
+            <a:avLst/>
+          </a:prstGeom>
+          <a:noFill/>
+        </p:spPr>
+        <p:txBody>
+          <a:bodyPr wrap="square" lIns="13716" rIns="13716" tIns="13716" bIns="13716">
+            <a:spAutoFit/>
+          </a:bodyPr>
+          <a:lstStyle/>
+          <a:p>
+            <a:pPr>
+              <a:spcAft>
+                <a:spcPts val="700"/>
+              </a:spcAft>
+              <a:defRPr sz="1700" b="0">
+                <a:solidFill>
+                  <a:srgbClr val="102C3B"/>
+                </a:solidFill>
+                <a:latin typeface="Aptos"/>
+              </a:defRPr>
+            </a:pPr>
+            <a:r>
+              <a:t>18,9 s</a:t>
+            </a:r>
+          </a:p>
+        </p:txBody>
+      </p:sp>
+      <p:sp>
+        <p:nvSpPr>
+          <p:cNvPr id="33" name="TextBox 32"/>
+          <p:cNvSpPr txBox="1"/>
+          <p:nvPr/>
+        </p:nvSpPr>
+        <p:spPr>
+          <a:xfrm>
+            <a:off x="7863840" y="4050791"/>
+            <a:ext cx="1463040" cy="393192"/>
+          </a:xfrm>
+          <a:prstGeom prst="rect">
+            <a:avLst/>
+          </a:prstGeom>
+          <a:noFill/>
+        </p:spPr>
+        <p:txBody>
+          <a:bodyPr wrap="square" lIns="13716" rIns="13716" tIns="13716" bIns="13716">
+            <a:spAutoFit/>
+          </a:bodyPr>
+          <a:lstStyle/>
+          <a:p>
+            <a:pPr>
+              <a:spcAft>
+                <a:spcPts val="700"/>
+              </a:spcAft>
+              <a:defRPr sz="1700" b="0">
+                <a:solidFill>
+                  <a:srgbClr val="102C3B"/>
+                </a:solidFill>
+                <a:latin typeface="Aptos"/>
+              </a:defRPr>
+            </a:pPr>
+            <a:r>
+              <a:t>27,1 s</a:t>
+            </a:r>
+          </a:p>
+        </p:txBody>
+      </p:sp>
+      <p:sp>
+        <p:nvSpPr>
+          <p:cNvPr id="34" name="TextBox 33"/>
+          <p:cNvSpPr txBox="1"/>
+          <p:nvPr/>
+        </p:nvSpPr>
+        <p:spPr>
+          <a:xfrm>
+            <a:off x="9418320" y="4050791"/>
+            <a:ext cx="2011680" cy="393192"/>
+          </a:xfrm>
+          <a:prstGeom prst="rect">
+            <a:avLst/>
+          </a:prstGeom>
+          <a:noFill/>
+        </p:spPr>
+        <p:txBody>
+          <a:bodyPr wrap="square" lIns="13716" rIns="13716" tIns="13716" bIns="13716">
+            <a:spAutoFit/>
+          </a:bodyPr>
+          <a:lstStyle/>
+          <a:p>
+            <a:pPr>
+              <a:spcAft>
+                <a:spcPts val="700"/>
+              </a:spcAft>
+              <a:defRPr sz="1700" b="0">
+                <a:solidFill>
+                  <a:srgbClr val="102C3B"/>
+                </a:solidFill>
+                <a:latin typeface="Aptos"/>
+              </a:defRPr>
+            </a:pPr>
+            <a:r>
+              <a:t>966 MB</a:t>
+            </a:r>
+          </a:p>
+        </p:txBody>
+      </p:sp>
+      <p:sp>
+        <p:nvSpPr>
+          <p:cNvPr id="35" name="Rectangle 34"/>
+          <p:cNvSpPr/>
+          <p:nvPr/>
+        </p:nvSpPr>
+        <p:spPr>
+          <a:xfrm>
+            <a:off x="548640" y="4562856"/>
+            <a:ext cx="11064240" cy="539496"/>
+          </a:xfrm>
+          <a:prstGeom prst="rect">
+            <a:avLst/>
+          </a:prstGeom>
+          <a:solidFill>
+            <a:srgbClr val="E3EFED"/>
+          </a:solidFill>
+          <a:ln>
+            <a:noFill/>
+          </a:ln>
+        </p:spPr>
+        <p:style>
+          <a:lnRef idx="1">
+            <a:schemeClr val="accent1"/>
+          </a:lnRef>
+          <a:fillRef idx="3">
+            <a:schemeClr val="accent1"/>
+          </a:fillRef>
+          <a:effectRef idx="2">
+            <a:schemeClr val="accent1"/>
+          </a:effectRef>
+          <a:fontRef idx="minor">
+            <a:schemeClr val="lt1"/>
+          </a:fontRef>
+        </p:style>
+        <p:txBody>
+          <a:bodyPr rtlCol="0" anchor="ctr"/>
+          <a:lstStyle/>
+          <a:p>
+            <a:pPr algn="ctr"/>
+          </a:p>
+        </p:txBody>
+      </p:sp>
+      <p:sp>
+        <p:nvSpPr>
+          <p:cNvPr id="36" name="TextBox 35"/>
+          <p:cNvSpPr txBox="1"/>
+          <p:nvPr/>
+        </p:nvSpPr>
+        <p:spPr>
+          <a:xfrm>
+            <a:off x="731520" y="4636008"/>
+            <a:ext cx="1463040" cy="393192"/>
+          </a:xfrm>
+          <a:prstGeom prst="rect">
+            <a:avLst/>
+          </a:prstGeom>
+          <a:noFill/>
+        </p:spPr>
+        <p:txBody>
+          <a:bodyPr wrap="square" lIns="13716" rIns="13716" tIns="13716" bIns="13716">
+            <a:spAutoFit/>
+          </a:bodyPr>
+          <a:lstStyle/>
+          <a:p>
+            <a:pPr>
+              <a:spcAft>
+                <a:spcPts val="700"/>
+              </a:spcAft>
+              <a:defRPr sz="1700" b="0">
+                <a:solidFill>
+                  <a:srgbClr val="102C3B"/>
+                </a:solidFill>
+                <a:latin typeface="Aptos"/>
+              </a:defRPr>
+            </a:pPr>
+            <a:r>
+              <a:t>10×</a:t>
+            </a:r>
+          </a:p>
+        </p:txBody>
+      </p:sp>
+      <p:sp>
+        <p:nvSpPr>
+          <p:cNvPr id="37" name="TextBox 36"/>
+          <p:cNvSpPr txBox="1"/>
+          <p:nvPr/>
+        </p:nvSpPr>
+        <p:spPr>
+          <a:xfrm>
+            <a:off x="2286000" y="4636008"/>
+            <a:ext cx="1691640" cy="393192"/>
+          </a:xfrm>
+          <a:prstGeom prst="rect">
+            <a:avLst/>
+          </a:prstGeom>
+          <a:noFill/>
+        </p:spPr>
+        <p:txBody>
+          <a:bodyPr wrap="square" lIns="13716" rIns="13716" tIns="13716" bIns="13716">
+            <a:spAutoFit/>
+          </a:bodyPr>
+          <a:lstStyle/>
+          <a:p>
+            <a:pPr>
+              <a:spcAft>
+                <a:spcPts val="700"/>
+              </a:spcAft>
+              <a:defRPr sz="1700" b="0">
+                <a:solidFill>
+                  <a:srgbClr val="102C3B"/>
+                </a:solidFill>
+                <a:latin typeface="Aptos"/>
+              </a:defRPr>
+            </a:pPr>
+            <a:r>
+              <a:t>707’670</a:t>
+            </a:r>
+          </a:p>
+        </p:txBody>
+      </p:sp>
+      <p:sp>
+        <p:nvSpPr>
+          <p:cNvPr id="38" name="TextBox 37"/>
+          <p:cNvSpPr txBox="1"/>
+          <p:nvPr/>
+        </p:nvSpPr>
+        <p:spPr>
+          <a:xfrm>
+            <a:off x="4069080" y="4636008"/>
+            <a:ext cx="1965960" cy="393192"/>
+          </a:xfrm>
+          <a:prstGeom prst="rect">
+            <a:avLst/>
+          </a:prstGeom>
+          <a:noFill/>
+        </p:spPr>
+        <p:txBody>
+          <a:bodyPr wrap="square" lIns="13716" rIns="13716" tIns="13716" bIns="13716">
+            <a:spAutoFit/>
+          </a:bodyPr>
+          <a:lstStyle/>
+          <a:p>
+            <a:pPr>
+              <a:spcAft>
+                <a:spcPts val="700"/>
+              </a:spcAft>
+              <a:defRPr sz="1700" b="0">
+                <a:solidFill>
+                  <a:srgbClr val="102C3B"/>
+                </a:solidFill>
+                <a:latin typeface="Aptos"/>
+              </a:defRPr>
+            </a:pPr>
+            <a:r>
+              <a:t>14,1 s</a:t>
+            </a:r>
+          </a:p>
+        </p:txBody>
+      </p:sp>
+      <p:sp>
+        <p:nvSpPr>
+          <p:cNvPr id="39" name="TextBox 38"/>
+          <p:cNvSpPr txBox="1"/>
+          <p:nvPr/>
+        </p:nvSpPr>
+        <p:spPr>
+          <a:xfrm>
+            <a:off x="6172200" y="4636008"/>
+            <a:ext cx="1600200" cy="393192"/>
+          </a:xfrm>
+          <a:prstGeom prst="rect">
+            <a:avLst/>
+          </a:prstGeom>
+          <a:noFill/>
+        </p:spPr>
+        <p:txBody>
+          <a:bodyPr wrap="square" lIns="13716" rIns="13716" tIns="13716" bIns="13716">
+            <a:spAutoFit/>
+          </a:bodyPr>
+          <a:lstStyle/>
+          <a:p>
+            <a:pPr>
+              <a:spcAft>
+                <a:spcPts val="700"/>
+              </a:spcAft>
+              <a:defRPr sz="1700" b="0">
+                <a:solidFill>
+                  <a:srgbClr val="102C3B"/>
+                </a:solidFill>
+                <a:latin typeface="Aptos"/>
+              </a:defRPr>
+            </a:pPr>
+            <a:r>
+              <a:t>39,9 s</a:t>
+            </a:r>
+          </a:p>
+        </p:txBody>
+      </p:sp>
+      <p:sp>
+        <p:nvSpPr>
+          <p:cNvPr id="40" name="TextBox 39"/>
+          <p:cNvSpPr txBox="1"/>
+          <p:nvPr/>
+        </p:nvSpPr>
+        <p:spPr>
+          <a:xfrm>
+            <a:off x="7863840" y="4636008"/>
+            <a:ext cx="1463040" cy="393192"/>
+          </a:xfrm>
+          <a:prstGeom prst="rect">
+            <a:avLst/>
+          </a:prstGeom>
+          <a:noFill/>
+        </p:spPr>
+        <p:txBody>
+          <a:bodyPr wrap="square" lIns="13716" rIns="13716" tIns="13716" bIns="13716">
+            <a:spAutoFit/>
+          </a:bodyPr>
+          <a:lstStyle/>
+          <a:p>
+            <a:pPr>
+              <a:spcAft>
+                <a:spcPts val="700"/>
+              </a:spcAft>
+              <a:defRPr sz="1700" b="0">
+                <a:solidFill>
+                  <a:srgbClr val="102C3B"/>
+                </a:solidFill>
+                <a:latin typeface="Aptos"/>
+              </a:defRPr>
+            </a:pPr>
+            <a:r>
+              <a:t>56,2 s</a:t>
+            </a:r>
+          </a:p>
+        </p:txBody>
+      </p:sp>
+      <p:sp>
+        <p:nvSpPr>
+          <p:cNvPr id="41" name="TextBox 40"/>
+          <p:cNvSpPr txBox="1"/>
+          <p:nvPr/>
+        </p:nvSpPr>
+        <p:spPr>
+          <a:xfrm>
+            <a:off x="9418320" y="4636008"/>
+            <a:ext cx="2011680" cy="393192"/>
+          </a:xfrm>
+          <a:prstGeom prst="rect">
+            <a:avLst/>
+          </a:prstGeom>
+          <a:noFill/>
+        </p:spPr>
+        <p:txBody>
+          <a:bodyPr wrap="square" lIns="13716" rIns="13716" tIns="13716" bIns="13716">
+            <a:spAutoFit/>
+          </a:bodyPr>
+          <a:lstStyle/>
+          <a:p>
+            <a:pPr>
+              <a:spcAft>
+                <a:spcPts val="700"/>
+              </a:spcAft>
+              <a:defRPr sz="1700" b="0">
+                <a:solidFill>
+                  <a:srgbClr val="102C3B"/>
+                </a:solidFill>
+                <a:latin typeface="Aptos"/>
+              </a:defRPr>
+            </a:pPr>
+            <a:r>
+              <a:t>1’835 MB</a:t>
+            </a:r>
+          </a:p>
+        </p:txBody>
+      </p:sp>
+      <p:sp>
+        <p:nvSpPr>
+          <p:cNvPr id="42" name="Rounded Rectangle 41"/>
+          <p:cNvSpPr/>
+          <p:nvPr/>
+        </p:nvSpPr>
+        <p:spPr>
+          <a:xfrm>
+            <a:off x="548640" y="5806440"/>
+            <a:ext cx="11064240" cy="484632"/>
+          </a:xfrm>
+          <a:prstGeom prst="roundRect">
+            <a:avLst>
+              <a:gd name="adj" fmla="val 8000"/>
+            </a:avLst>
+          </a:prstGeom>
+          <a:solidFill>
+            <a:srgbClr val="E3EFED"/>
+          </a:solidFill>
+          <a:ln>
+            <a:noFill/>
+          </a:ln>
+        </p:spPr>
+        <p:style>
+          <a:lnRef idx="1">
+            <a:schemeClr val="accent1"/>
+          </a:lnRef>
+          <a:fillRef idx="3">
+            <a:schemeClr val="accent1"/>
+          </a:fillRef>
+          <a:effectRef idx="2">
+            <a:schemeClr val="accent1"/>
+          </a:effectRef>
+          <a:fontRef idx="minor">
+            <a:schemeClr val="lt1"/>
+          </a:fontRef>
+        </p:style>
+        <p:txBody>
+          <a:bodyPr rtlCol="0" anchor="ctr"/>
+          <a:lstStyle/>
+          <a:p>
+            <a:pPr algn="ctr"/>
+          </a:p>
+        </p:txBody>
+      </p:sp>
+      <p:sp>
+        <p:nvSpPr>
+          <p:cNvPr id="43" name="TextBox 42"/>
+          <p:cNvSpPr txBox="1"/>
+          <p:nvPr/>
+        </p:nvSpPr>
+        <p:spPr>
+          <a:xfrm>
+            <a:off x="740664" y="5888736"/>
+            <a:ext cx="10652760" cy="329184"/>
+          </a:xfrm>
+          <a:prstGeom prst="rect">
+            <a:avLst/>
+          </a:prstGeom>
+          <a:noFill/>
+        </p:spPr>
+        <p:txBody>
+          <a:bodyPr wrap="square" lIns="13716" rIns="13716" tIns="13716" bIns="13716">
+            <a:spAutoFit/>
+          </a:bodyPr>
+          <a:lstStyle/>
+          <a:p>
+            <a:pPr>
+              <a:spcAft>
+                <a:spcPts val="700"/>
+              </a:spcAft>
+              <a:defRPr sz="1700" b="1">
+                <a:solidFill>
+                  <a:srgbClr val="102C3B"/>
+                </a:solidFill>
+                <a:latin typeface="Aptos"/>
+              </a:defRPr>
+            </a:pPr>
+            <a:r>
+              <a:t>Grenze ist der Arbeitsspeicher: Mit 8 GB reicht der Entwurf für das 30- bis 40-Fache.</a:t>
+            </a:r>
+          </a:p>
+        </p:txBody>
+      </p:sp>
+      <p:sp>
+        <p:nvSpPr>
+          <p:cNvPr id="44" name="TextBox 43"/>
+          <p:cNvSpPr txBox="1"/>
+          <p:nvPr/>
+        </p:nvSpPr>
+        <p:spPr>
+          <a:xfrm>
+            <a:off x="566928" y="6318504"/>
+            <a:ext cx="10607040" cy="173736"/>
+          </a:xfrm>
+          <a:prstGeom prst="rect">
+            <a:avLst/>
+          </a:prstGeom>
+          <a:noFill/>
+        </p:spPr>
+        <p:txBody>
+          <a:bodyPr wrap="square" lIns="13716" rIns="13716" tIns="13716" bIns="13716">
+            <a:spAutoFit/>
+          </a:bodyPr>
+          <a:lstStyle/>
+          <a:p>
+            <a:pPr>
+              <a:spcAft>
+                <a:spcPts val="700"/>
+              </a:spcAft>
+              <a:defRPr sz="800" b="0">
+                <a:solidFill>
+                  <a:srgbClr val="536773"/>
+                </a:solidFill>
+                <a:latin typeface="Aptos"/>
+              </a:defRPr>
+            </a:pPr>
+            <a:r>
+              <a:t>Nachweis: src/de_projekt/benchmark.py · data/processed/scaling_benchmark.csv · macOS (Apple Silicon), Python 3.14.7, 26.10.2026</a:t>
             </a:r>
           </a:p>
         </p:txBody>
@@ -19945,7 +21768,7 @@
               </a:defRPr>
             </a:pPr>
             <a:r>
-              <a:t>07 · METHODEN</a:t>
+              <a:t>08 · METHODEN</a:t>
             </a:r>
           </a:p>
         </p:txBody>
@@ -20101,7 +21924,7 @@
               </a:defRPr>
             </a:pPr>
             <a:r>
-              <a:t>08</a:t>
+              <a:t>09</a:t>
             </a:r>
           </a:p>
         </p:txBody>
@@ -20818,7 +22641,7 @@
               </a:defRPr>
             </a:pPr>
             <a:r>
-              <a:t>08 · ERGEBNIS F1</a:t>
+              <a:t>09 · ERGEBNIS F1</a:t>
             </a:r>
           </a:p>
         </p:txBody>
@@ -20974,7 +22797,7 @@
               </a:defRPr>
             </a:pPr>
             <a:r>
-              <a:t>09</a:t>
+              <a:t>10</a:t>
             </a:r>
           </a:p>
         </p:txBody>

</xml_diff>